<commit_message>
Remove named person from copy, drop register username, dropdown machines
Enquiry machine type is chosen from the catalogue. Registration no
longer asks for a username; login still accepts email.

Co-authored-by: dilwalanoor143 <dilwalanoor143@gmail.com>
</commit_message>
<xml_diff>
--- a/docs/SARA-ROSE-Client-Demo.pptx
+++ b/docs/SARA-ROSE-Client-Demo.pptx
@@ -516,7 +516,7 @@
           <a:lstStyle/>
           <a:p>
             <a:r>
-              <a:t>Open with the company name and the purpose of the meeting: this is the working website, not a brochure mock-up. Mention Sagamu / Ogun State and that the named contact remains Mr. Akram Haider.</a:t>
+              <a:t>Open with the company name and the purpose of the meeting: this is the working website, not a brochure mock-up. Mention Sagamu / Ogun State and the telephone and email on the site.</a:t>
             </a:r>
           </a:p>
         </p:txBody>
@@ -5109,8 +5109,7 @@
                 </a:solidFill>
                 <a:latin typeface="Calibri"/>
               </a:rPr>
-              <a:t>Mr. Akram Haider
-+234 80 6665 1111
+              <a:t>+234 80 6665 1111
 contact@sararose.com</a:t>
             </a:r>
           </a:p>
@@ -7610,7 +7609,7 @@
                 </a:solidFill>
                 <a:latin typeface="Calibri"/>
               </a:rPr>
-              <a:t>Mr. Akram Haider  ·  +234 80 6665 1111  ·  contact@sararose.com</a:t>
+              <a:t>+234 80 6665 1111  ·  contact@sararose.com</a:t>
             </a:r>
           </a:p>
           <a:p>
@@ -8359,7 +8358,7 @@
                 </a:solidFill>
                 <a:latin typeface="Calibri"/>
               </a:rPr>
-              <a:t>▸  Every commercial conversation has a named person: Mr. Akram Haider.</a:t>
+              <a:t>▸  Enquiries go by phone or email. The conversation stays accountable from first contact onward.</a:t>
             </a:r>
           </a:p>
         </p:txBody>
@@ -10794,7 +10793,7 @@
                 </a:solidFill>
                 <a:latin typeface="Calibri"/>
               </a:rPr>
-              <a:t>▸  Commercially, the conversation still belongs to Mr. Akram Haider.</a:t>
+              <a:t>▸  Commercially, the conversation is followed up by telephone and email.</a:t>
             </a:r>
           </a:p>
           <a:p>

</xml_diff>